<commit_message>
docs: remove speaker notes from the shipped presentation
The discussion has happened, so the presenter cue cards no longer need to ship
with the deck. Removed the addNotes() calls from the generator and regenerated,
so the artifact and its source stay consistent — regenerating will not bring the
notes back.

Slides, layout and content are unchanged: 9 slides, validation passes, notes
text no longer appears anywhere in the package XML. The annotated copy is kept
locally and git-ignored.
</commit_message>
<xml_diff>
--- a/presentation/Badeel-Presentation.pptx
+++ b/presentation/Badeel-Presentation.pptx
@@ -510,7 +510,7 @@
           <a:p>
             <a:r>
               <a:rPr lang="en-US" dirty="0"/>
-              <a:t>Open calm. Name the project, then go straight to the problem — don't list technologies yet.</a:t>
+              <a:t/>
             </a:r>
             <a:endParaRPr lang="en-US" dirty="0"/>
           </a:p>
@@ -598,7 +598,7 @@
           <a:p>
             <a:r>
               <a:rPr lang="en-US" dirty="0"/>
-              <a:t>Set the scene in three beats. End on: this is a clinical decision made under pressure.</a:t>
+              <a:t/>
             </a:r>
             <a:endParaRPr lang="en-US" dirty="0"/>
           </a:p>
@@ -686,7 +686,7 @@
           <a:p>
             <a:r>
               <a:rPr lang="en-US" dirty="0"/>
-              <a:t>This is the slide that frames everything. Land the contrast, then move on quickly.</a:t>
+              <a:t/>
             </a:r>
             <a:endParaRPr lang="en-US" dirty="0"/>
           </a:p>
@@ -774,7 +774,7 @@
           <a:p>
             <a:r>
               <a:rPr lang="en-US" dirty="0"/>
-              <a:t>Three roles, strictly separated. Say it plainly: the model finds facts, Python makes decisions.</a:t>
+              <a:t/>
             </a:r>
             <a:endParaRPr lang="en-US" dirty="0"/>
           </a:p>
@@ -862,7 +862,7 @@
           <a:p>
             <a:r>
               <a:rPr lang="en-US" dirty="0"/>
-              <a:t>Don't read all six. Say: it never suggests before it screens, and point at the last line.</a:t>
+              <a:t/>
             </a:r>
             <a:endParaRPr lang="en-US" dirty="0"/>
           </a:p>
@@ -950,7 +950,7 @@
           <a:p>
             <a:r>
               <a:rPr lang="en-US" dirty="0"/>
-              <a:t>This is the 'new idea' the brief asks for. Use the doorman line — it lands with everyone.</a:t>
+              <a:t/>
             </a:r>
             <a:endParaRPr lang="en-US" dirty="0"/>
           </a:p>
@@ -1038,7 +1038,7 @@
           <a:p>
             <a:r>
               <a:rPr lang="en-US" dirty="0"/>
-              <a:t>Switch to the browser here. Do NOT read this list aloud — it is a map for you.</a:t>
+              <a:t/>
             </a:r>
             <a:endParaRPr lang="en-US" dirty="0"/>
           </a:p>
@@ -1126,7 +1126,7 @@
           <a:p>
             <a:r>
               <a:rPr lang="en-US" dirty="0"/>
-              <a:t>Lead with the two 100% rows side by side. The 7% -&gt; 57% line is the punchline.</a:t>
+              <a:t/>
             </a:r>
             <a:endParaRPr lang="en-US" dirty="0"/>
           </a:p>
@@ -1214,7 +1214,7 @@
           <a:p>
             <a:r>
               <a:rPr lang="en-US" dirty="0"/>
-              <a:t>Say the two lines slowly. Then stop talking and take questions.</a:t>
+              <a:t/>
             </a:r>
             <a:endParaRPr lang="en-US" dirty="0"/>
           </a:p>

</xml_diff>